<commit_message>
fix: name enterprise AI platforms in support workflow deck
Address reviewer feedback (AI Integration): replace generic AI labels
with named enterprise platforms across the AI solution/workflow slides.
- Chatbot + proactive updates -> Intercom Fin
- Ticket creation, summarization, routing -> Salesforce Einstein (Automatic Routing Engine)
- Knowledge assistant -> Microsoft Copilot for Service
</commit_message>
<xml_diff>
--- a/projects/ai-powered-customer-support-workflow/AI-Powered-Customer-Support-Workflow-Jason-Teixeira-Revised-with-Complaints.pptx
+++ b/projects/ai-powered-customer-support-workflow/AI-Powered-Customer-Support-Workflow-Jason-Teixeira-Revised-with-Complaints.pptx
@@ -1980,6 +1980,10 @@
             <a:prstDash val="solid"/>
           </a:ln>
         </p:spPr>
+        <p:txBody>
+          <a:bodyPr/>
+          <a:p/>
+        </p:txBody>
       </p:sp>
       <p:sp>
         <p:nvSpPr>
@@ -2009,6 +2013,10 @@
             <a:prstDash val="solid"/>
           </a:ln>
         </p:spPr>
+        <p:txBody>
+          <a:bodyPr/>
+          <a:p/>
+        </p:txBody>
       </p:sp>
       <p:sp>
         <p:nvSpPr>
@@ -2110,6 +2118,10 @@
             <a:prstDash val="solid"/>
           </a:ln>
         </p:spPr>
+        <p:txBody>
+          <a:bodyPr/>
+          <a:p/>
+        </p:txBody>
       </p:sp>
       <p:sp>
         <p:nvSpPr>
@@ -2175,6 +2187,10 @@
             <a:prstDash val="solid"/>
           </a:ln>
         </p:spPr>
+        <p:txBody>
+          <a:bodyPr/>
+          <a:p/>
+        </p:txBody>
       </p:sp>
       <p:sp>
         <p:nvSpPr>
@@ -2381,6 +2397,10 @@
             <a:prstDash val="solid"/>
           </a:ln>
         </p:spPr>
+        <p:txBody>
+          <a:bodyPr/>
+          <a:p/>
+        </p:txBody>
       </p:sp>
       <p:sp>
         <p:nvSpPr>
@@ -2520,6 +2540,10 @@
             <a:prstDash val="solid"/>
           </a:ln>
         </p:spPr>
+        <p:txBody>
+          <a:bodyPr/>
+          <a:p/>
+        </p:txBody>
       </p:sp>
       <p:sp>
         <p:nvSpPr>
@@ -2659,6 +2683,10 @@
             <a:prstDash val="solid"/>
           </a:ln>
         </p:spPr>
+        <p:txBody>
+          <a:bodyPr/>
+          <a:p/>
+        </p:txBody>
       </p:sp>
       <p:sp>
         <p:nvSpPr>
@@ -2798,6 +2826,10 @@
             <a:prstDash val="solid"/>
           </a:ln>
         </p:spPr>
+        <p:txBody>
+          <a:bodyPr/>
+          <a:p/>
+        </p:txBody>
       </p:sp>
       <p:sp>
         <p:nvSpPr>
@@ -3120,6 +3152,10 @@
             <a:prstDash val="solid"/>
           </a:ln>
         </p:spPr>
+        <p:txBody>
+          <a:bodyPr/>
+          <a:p/>
+        </p:txBody>
       </p:sp>
       <p:sp>
         <p:nvSpPr>
@@ -3147,6 +3183,10 @@
             <a:prstDash val="solid"/>
           </a:ln>
         </p:spPr>
+        <p:txBody>
+          <a:bodyPr/>
+          <a:p/>
+        </p:txBody>
       </p:sp>
       <p:sp>
         <p:nvSpPr>
@@ -3174,6 +3214,10 @@
             <a:prstDash val="solid"/>
           </a:ln>
         </p:spPr>
+        <p:txBody>
+          <a:bodyPr/>
+          <a:p/>
+        </p:txBody>
       </p:sp>
       <p:sp>
         <p:nvSpPr>
@@ -3201,6 +3245,10 @@
             <a:prstDash val="solid"/>
           </a:ln>
         </p:spPr>
+        <p:txBody>
+          <a:bodyPr/>
+          <a:p/>
+        </p:txBody>
       </p:sp>
       <p:sp>
         <p:nvSpPr>
@@ -3228,6 +3276,10 @@
             <a:prstDash val="solid"/>
           </a:ln>
         </p:spPr>
+        <p:txBody>
+          <a:bodyPr/>
+          <a:p/>
+        </p:txBody>
       </p:sp>
       <p:sp>
         <p:nvSpPr>
@@ -3255,6 +3307,10 @@
             <a:prstDash val="solid"/>
           </a:ln>
         </p:spPr>
+        <p:txBody>
+          <a:bodyPr/>
+          <a:p/>
+        </p:txBody>
       </p:sp>
       <p:sp>
         <p:nvSpPr>
@@ -3282,6 +3338,10 @@
             <a:prstDash val="solid"/>
           </a:ln>
         </p:spPr>
+        <p:txBody>
+          <a:bodyPr/>
+          <a:p/>
+        </p:txBody>
       </p:sp>
       <p:sp>
         <p:nvSpPr>
@@ -3383,6 +3443,10 @@
             <a:prstDash val="solid"/>
           </a:ln>
         </p:spPr>
+        <p:txBody>
+          <a:bodyPr/>
+          <a:p/>
+        </p:txBody>
       </p:sp>
       <p:sp>
         <p:nvSpPr>
@@ -3484,6 +3548,10 @@
             <a:prstDash val="solid"/>
           </a:ln>
         </p:spPr>
+        <p:txBody>
+          <a:bodyPr/>
+          <a:p/>
+        </p:txBody>
       </p:sp>
       <p:sp>
         <p:nvSpPr>
@@ -3585,6 +3653,10 @@
             <a:prstDash val="solid"/>
           </a:ln>
         </p:spPr>
+        <p:txBody>
+          <a:bodyPr/>
+          <a:p/>
+        </p:txBody>
       </p:sp>
       <p:sp>
         <p:nvSpPr>
@@ -3686,6 +3758,10 @@
             <a:prstDash val="solid"/>
           </a:ln>
         </p:spPr>
+        <p:txBody>
+          <a:bodyPr/>
+          <a:p/>
+        </p:txBody>
       </p:sp>
       <p:sp>
         <p:nvSpPr>
@@ -3787,6 +3863,10 @@
             <a:prstDash val="solid"/>
           </a:ln>
         </p:spPr>
+        <p:txBody>
+          <a:bodyPr/>
+          <a:p/>
+        </p:txBody>
       </p:sp>
       <p:sp>
         <p:nvSpPr>
@@ -3888,6 +3968,10 @@
             <a:prstDash val="solid"/>
           </a:ln>
         </p:spPr>
+        <p:txBody>
+          <a:bodyPr/>
+          <a:p/>
+        </p:txBody>
       </p:sp>
       <p:sp>
         <p:nvSpPr>
@@ -3989,6 +4073,10 @@
             <a:prstDash val="solid"/>
           </a:ln>
         </p:spPr>
+        <p:txBody>
+          <a:bodyPr/>
+          <a:p/>
+        </p:txBody>
       </p:sp>
       <p:sp>
         <p:nvSpPr>
@@ -4235,6 +4323,10 @@
             <a:prstDash val="solid"/>
           </a:ln>
         </p:spPr>
+        <p:txBody>
+          <a:bodyPr/>
+          <a:p/>
+        </p:txBody>
       </p:sp>
       <p:sp>
         <p:nvSpPr>
@@ -4446,6 +4538,10 @@
             <a:prstDash val="solid"/>
           </a:ln>
         </p:spPr>
+        <p:txBody>
+          <a:bodyPr/>
+          <a:p/>
+        </p:txBody>
       </p:sp>
       <p:sp>
         <p:nvSpPr>
@@ -4507,6 +4603,10 @@
             <a:prstDash val="solid"/>
           </a:ln>
         </p:spPr>
+        <p:txBody>
+          <a:bodyPr/>
+          <a:p/>
+        </p:txBody>
       </p:sp>
       <p:sp>
         <p:nvSpPr>
@@ -4646,6 +4746,10 @@
             <a:prstDash val="solid"/>
           </a:ln>
         </p:spPr>
+        <p:txBody>
+          <a:bodyPr/>
+          <a:p/>
+        </p:txBody>
       </p:sp>
       <p:sp>
         <p:nvSpPr>
@@ -4785,6 +4889,10 @@
             <a:prstDash val="solid"/>
           </a:ln>
         </p:spPr>
+        <p:txBody>
+          <a:bodyPr/>
+          <a:p/>
+        </p:txBody>
       </p:sp>
       <p:sp>
         <p:nvSpPr>
@@ -4924,6 +5032,10 @@
             <a:prstDash val="solid"/>
           </a:ln>
         </p:spPr>
+        <p:txBody>
+          <a:bodyPr/>
+          <a:p/>
+        </p:txBody>
       </p:sp>
       <p:sp>
         <p:nvSpPr>
@@ -5063,6 +5175,10 @@
             <a:prstDash val="solid"/>
           </a:ln>
         </p:spPr>
+        <p:txBody>
+          <a:bodyPr/>
+          <a:p/>
+        </p:txBody>
       </p:sp>
       <p:sp>
         <p:nvSpPr>
@@ -5202,6 +5318,10 @@
             <a:prstDash val="solid"/>
           </a:ln>
         </p:spPr>
+        <p:txBody>
+          <a:bodyPr/>
+          <a:p/>
+        </p:txBody>
       </p:sp>
       <p:sp>
         <p:nvSpPr>
@@ -5341,6 +5461,10 @@
             <a:prstDash val="solid"/>
           </a:ln>
         </p:spPr>
+        <p:txBody>
+          <a:bodyPr/>
+          <a:p/>
+        </p:txBody>
       </p:sp>
       <p:sp>
         <p:nvSpPr>
@@ -5480,6 +5604,10 @@
             <a:prstDash val="solid"/>
           </a:ln>
         </p:spPr>
+        <p:txBody>
+          <a:bodyPr/>
+          <a:p/>
+        </p:txBody>
       </p:sp>
       <p:sp>
         <p:nvSpPr>
@@ -5802,6 +5930,10 @@
             <a:prstDash val="solid"/>
           </a:ln>
         </p:spPr>
+        <p:txBody>
+          <a:bodyPr/>
+          <a:p/>
+        </p:txBody>
       </p:sp>
       <p:sp>
         <p:nvSpPr>
@@ -6053,6 +6185,10 @@
             <a:prstDash val="solid"/>
           </a:ln>
         </p:spPr>
+        <p:txBody>
+          <a:bodyPr/>
+          <a:p/>
+        </p:txBody>
       </p:sp>
       <p:sp>
         <p:nvSpPr>
@@ -6304,6 +6440,10 @@
             <a:prstDash val="solid"/>
           </a:ln>
         </p:spPr>
+        <p:txBody>
+          <a:bodyPr/>
+          <a:p/>
+        </p:txBody>
       </p:sp>
       <p:sp>
         <p:nvSpPr>
@@ -6700,6 +6840,10 @@
             <a:prstDash val="solid"/>
           </a:ln>
         </p:spPr>
+        <p:txBody>
+          <a:bodyPr/>
+          <a:p/>
+        </p:txBody>
       </p:sp>
       <p:sp>
         <p:nvSpPr>
@@ -6835,6 +6979,10 @@
             <a:prstDash val="solid"/>
           </a:ln>
         </p:spPr>
+        <p:txBody>
+          <a:bodyPr/>
+          <a:p/>
+        </p:txBody>
       </p:sp>
       <p:sp>
         <p:nvSpPr>
@@ -6906,7 +7054,7 @@
                   <a:srgbClr val="16A34A"/>
                 </a:solidFill>
               </a:rPr>
-              <a:t>AI chatbot + automated status updates</a:t>
+              <a:t>Intercom Fin (conversational AI agent + proactive updates)</a:t>
             </a:r>
             <a:endParaRPr lang="en-US" sz="1060" dirty="0"/>
           </a:p>
@@ -6976,6 +7124,10 @@
             <a:prstDash val="solid"/>
           </a:ln>
         </p:spPr>
+        <p:txBody>
+          <a:bodyPr/>
+          <a:p/>
+        </p:txBody>
       </p:sp>
       <p:sp>
         <p:nvSpPr>
@@ -7047,7 +7199,7 @@
                   <a:srgbClr val="16A34A"/>
                 </a:solidFill>
               </a:rPr>
-              <a:t>AI ticket intake + CRM summarization</a:t>
+              <a:t>Salesforce Einstein (case creation + case summaries)</a:t>
             </a:r>
             <a:endParaRPr lang="en-US" sz="1060" dirty="0"/>
           </a:p>
@@ -7117,6 +7269,10 @@
             <a:prstDash val="solid"/>
           </a:ln>
         </p:spPr>
+        <p:txBody>
+          <a:bodyPr/>
+          <a:p/>
+        </p:txBody>
       </p:sp>
       <p:sp>
         <p:nvSpPr>
@@ -7188,7 +7344,7 @@
                   <a:srgbClr val="16A34A"/>
                 </a:solidFill>
               </a:rPr>
-              <a:t>AI knowledge assistant</a:t>
+              <a:t>Microsoft Copilot for Service (RAG knowledge assistant)</a:t>
             </a:r>
             <a:endParaRPr lang="en-US" sz="1060" dirty="0"/>
           </a:p>
@@ -7258,6 +7414,10 @@
             <a:prstDash val="solid"/>
           </a:ln>
         </p:spPr>
+        <p:txBody>
+          <a:bodyPr/>
+          <a:p/>
+        </p:txBody>
       </p:sp>
       <p:sp>
         <p:nvSpPr>
@@ -7329,7 +7489,7 @@
                   <a:srgbClr val="16A34A"/>
                 </a:solidFill>
               </a:rPr>
-              <a:t>AI ticket routing</a:t>
+              <a:t>Salesforce Einstein Automatic Routing Engine</a:t>
             </a:r>
             <a:endParaRPr lang="en-US" sz="1060" dirty="0"/>
           </a:p>
@@ -7399,6 +7559,10 @@
             <a:prstDash val="solid"/>
           </a:ln>
         </p:spPr>
+        <p:txBody>
+          <a:bodyPr/>
+          <a:p/>
+        </p:txBody>
       </p:sp>
       <p:sp>
         <p:nvSpPr>
@@ -7609,6 +7773,10 @@
             <a:prstDash val="solid"/>
           </a:ln>
         </p:spPr>
+        <p:txBody>
+          <a:bodyPr/>
+          <a:p/>
+        </p:txBody>
       </p:sp>
       <p:sp>
         <p:nvSpPr>
@@ -7636,6 +7804,10 @@
             <a:prstDash val="solid"/>
           </a:ln>
         </p:spPr>
+        <p:txBody>
+          <a:bodyPr/>
+          <a:p/>
+        </p:txBody>
       </p:sp>
       <p:sp>
         <p:nvSpPr>
@@ -7663,6 +7835,10 @@
             <a:prstDash val="solid"/>
           </a:ln>
         </p:spPr>
+        <p:txBody>
+          <a:bodyPr/>
+          <a:p/>
+        </p:txBody>
       </p:sp>
       <p:sp>
         <p:nvSpPr>
@@ -7690,6 +7866,10 @@
             <a:prstDash val="solid"/>
           </a:ln>
         </p:spPr>
+        <p:txBody>
+          <a:bodyPr/>
+          <a:p/>
+        </p:txBody>
       </p:sp>
       <p:sp>
         <p:nvSpPr>
@@ -7717,6 +7897,10 @@
             <a:prstDash val="solid"/>
           </a:ln>
         </p:spPr>
+        <p:txBody>
+          <a:bodyPr/>
+          <a:p/>
+        </p:txBody>
       </p:sp>
       <p:sp>
         <p:nvSpPr>
@@ -7744,6 +7928,10 @@
             <a:prstDash val="solid"/>
           </a:ln>
         </p:spPr>
+        <p:txBody>
+          <a:bodyPr/>
+          <a:p/>
+        </p:txBody>
       </p:sp>
       <p:sp>
         <p:nvSpPr>
@@ -7771,6 +7959,10 @@
             <a:prstDash val="solid"/>
           </a:ln>
         </p:spPr>
+        <p:txBody>
+          <a:bodyPr/>
+          <a:p/>
+        </p:txBody>
       </p:sp>
       <p:sp>
         <p:nvSpPr>
@@ -7872,6 +8064,10 @@
             <a:prstDash val="solid"/>
           </a:ln>
         </p:spPr>
+        <p:txBody>
+          <a:bodyPr/>
+          <a:p/>
+        </p:txBody>
       </p:sp>
       <p:sp>
         <p:nvSpPr>
@@ -7903,7 +8099,7 @@
                   <a:srgbClr val="16A34A"/>
                 </a:solidFill>
               </a:rPr>
-              <a:t>AI</a:t>
+              <a:t>Salesforce Einstein</a:t>
             </a:r>
             <a:endParaRPr lang="en-US" sz="780" dirty="0"/>
           </a:p>
@@ -7973,6 +8169,10 @@
             <a:prstDash val="solid"/>
           </a:ln>
         </p:spPr>
+        <p:txBody>
+          <a:bodyPr/>
+          <a:p/>
+        </p:txBody>
       </p:sp>
       <p:sp>
         <p:nvSpPr>
@@ -8004,7 +8204,7 @@
                   <a:srgbClr val="16A34A"/>
                 </a:solidFill>
               </a:rPr>
-              <a:t>AI</a:t>
+              <a:t>Salesforce Einstein</a:t>
             </a:r>
             <a:endParaRPr lang="en-US" sz="780" dirty="0"/>
           </a:p>
@@ -8074,6 +8274,10 @@
             <a:prstDash val="solid"/>
           </a:ln>
         </p:spPr>
+        <p:txBody>
+          <a:bodyPr/>
+          <a:p/>
+        </p:txBody>
       </p:sp>
       <p:sp>
         <p:nvSpPr>
@@ -8105,7 +8309,7 @@
                   <a:srgbClr val="16A34A"/>
                 </a:solidFill>
               </a:rPr>
-              <a:t>AI</a:t>
+              <a:t>Salesforce Einstein</a:t>
             </a:r>
             <a:endParaRPr lang="en-US" sz="780" dirty="0"/>
           </a:p>
@@ -8175,6 +8379,10 @@
             <a:prstDash val="solid"/>
           </a:ln>
         </p:spPr>
+        <p:txBody>
+          <a:bodyPr/>
+          <a:p/>
+        </p:txBody>
       </p:sp>
       <p:sp>
         <p:nvSpPr>
@@ -8244,7 +8452,7 @@
                   <a:srgbClr val="172033"/>
                 </a:solidFill>
               </a:rPr>
-              <a:t>Uses AI knowledge assistant to resolve issue</a:t>
+              <a:t>Uses Microsoft Copilot for Service to resolve issue</a:t>
             </a:r>
             <a:endParaRPr lang="en-US" sz="830" dirty="0"/>
           </a:p>
@@ -8276,6 +8484,10 @@
             <a:prstDash val="solid"/>
           </a:ln>
         </p:spPr>
+        <p:txBody>
+          <a:bodyPr/>
+          <a:p/>
+        </p:txBody>
       </p:sp>
       <p:sp>
         <p:nvSpPr>
@@ -8307,7 +8519,7 @@
                   <a:srgbClr val="16A34A"/>
                 </a:solidFill>
               </a:rPr>
-              <a:t>AI + Human</a:t>
+              <a:t>Intercom Fin + Human</a:t>
             </a:r>
             <a:endParaRPr lang="en-US" sz="780" dirty="0"/>
           </a:p>
@@ -8377,6 +8589,10 @@
             <a:prstDash val="solid"/>
           </a:ln>
         </p:spPr>
+        <p:txBody>
+          <a:bodyPr/>
+          <a:p/>
+        </p:txBody>
       </p:sp>
       <p:sp>
         <p:nvSpPr>
@@ -8408,7 +8624,7 @@
                   <a:srgbClr val="16A34A"/>
                 </a:solidFill>
               </a:rPr>
-              <a:t>AI</a:t>
+              <a:t>Salesforce Einstein</a:t>
             </a:r>
             <a:endParaRPr lang="en-US" sz="780" dirty="0"/>
           </a:p>
@@ -8478,6 +8694,10 @@
             <a:prstDash val="solid"/>
           </a:ln>
         </p:spPr>
+        <p:txBody>
+          <a:bodyPr/>
+          <a:p/>
+        </p:txBody>
       </p:sp>
       <p:sp>
         <p:nvSpPr>
@@ -8615,6 +8835,10 @@
             <a:prstDash val="solid"/>
           </a:ln>
         </p:spPr>
+        <p:txBody>
+          <a:bodyPr/>
+          <a:p/>
+        </p:txBody>
       </p:sp>
       <p:sp>
         <p:nvSpPr>
@@ -8897,6 +9121,10 @@
             <a:prstDash val="solid"/>
           </a:ln>
         </p:spPr>
+        <p:txBody>
+          <a:bodyPr/>
+          <a:p/>
+        </p:txBody>
       </p:sp>
       <p:sp>
         <p:nvSpPr>
@@ -8924,6 +9152,10 @@
             <a:prstDash val="solid"/>
           </a:ln>
         </p:spPr>
+        <p:txBody>
+          <a:bodyPr/>
+          <a:p/>
+        </p:txBody>
       </p:sp>
       <p:sp>
         <p:nvSpPr>
@@ -9029,7 +9261,7 @@
                   <a:srgbClr val="172033"/>
                 </a:solidFill>
               </a:rPr>
-              <a:t>AI intake, acknowledgement, and routing shorten the time between customer contact and useful action.</a:t>
+              <a:t>Salesforce Einstein intake and routing, plus Intercom Fin acknowledgements, shorten the time between customer contact and useful action.</a:t>
             </a:r>
             <a:endParaRPr lang="en-US" sz="1040" dirty="0"/>
           </a:p>
@@ -9061,6 +9293,10 @@
             <a:prstDash val="solid"/>
           </a:ln>
         </p:spPr>
+        <p:txBody>
+          <a:bodyPr/>
+          <a:p/>
+        </p:txBody>
       </p:sp>
       <p:sp>
         <p:nvSpPr>
@@ -9088,6 +9324,10 @@
             <a:prstDash val="solid"/>
           </a:ln>
         </p:spPr>
+        <p:txBody>
+          <a:bodyPr/>
+          <a:p/>
+        </p:txBody>
       </p:sp>
       <p:sp>
         <p:nvSpPr>
@@ -9225,6 +9465,10 @@
             <a:prstDash val="solid"/>
           </a:ln>
         </p:spPr>
+        <p:txBody>
+          <a:bodyPr/>
+          <a:p/>
+        </p:txBody>
       </p:sp>
       <p:sp>
         <p:nvSpPr>
@@ -9252,6 +9496,10 @@
             <a:prstDash val="solid"/>
           </a:ln>
         </p:spPr>
+        <p:txBody>
+          <a:bodyPr/>
+          <a:p/>
+        </p:txBody>
       </p:sp>
       <p:sp>
         <p:nvSpPr>
@@ -9357,7 +9605,7 @@
                   <a:srgbClr val="172033"/>
                 </a:solidFill>
               </a:rPr>
-              <a:t>AI knowledge support gives CSRs approved information and reduces conflicting or generic responses.</a:t>
+              <a:t>Microsoft Copilot for Service gives CSRs approved information and reduces conflicting or generic responses.</a:t>
             </a:r>
             <a:endParaRPr lang="en-US" sz="1040" dirty="0"/>
           </a:p>
@@ -9389,6 +9637,10 @@
             <a:prstDash val="solid"/>
           </a:ln>
         </p:spPr>
+        <p:txBody>
+          <a:bodyPr/>
+          <a:p/>
+        </p:txBody>
       </p:sp>
       <p:sp>
         <p:nvSpPr>
@@ -9416,6 +9668,10 @@
             <a:prstDash val="solid"/>
           </a:ln>
         </p:spPr>
+        <p:txBody>
+          <a:bodyPr/>
+          <a:p/>
+        </p:txBody>
       </p:sp>
       <p:sp>
         <p:nvSpPr>
@@ -9553,6 +9809,10 @@
             <a:prstDash val="solid"/>
           </a:ln>
         </p:spPr>
+        <p:txBody>
+          <a:bodyPr/>
+          <a:p/>
+        </p:txBody>
       </p:sp>
       <p:sp>
         <p:nvSpPr>
@@ -9871,6 +10131,10 @@
             <a:prstDash val="solid"/>
           </a:ln>
         </p:spPr>
+        <p:txBody>
+          <a:bodyPr/>
+          <a:p/>
+        </p:txBody>
       </p:sp>
       <p:sp>
         <p:nvSpPr>
@@ -10012,6 +10276,10 @@
             <a:prstDash val="solid"/>
           </a:ln>
         </p:spPr>
+        <p:txBody>
+          <a:bodyPr/>
+          <a:p/>
+        </p:txBody>
       </p:sp>
       <p:sp>
         <p:nvSpPr>
@@ -10153,6 +10421,10 @@
             <a:prstDash val="solid"/>
           </a:ln>
         </p:spPr>
+        <p:txBody>
+          <a:bodyPr/>
+          <a:p/>
+        </p:txBody>
       </p:sp>
       <p:sp>
         <p:nvSpPr>
@@ -10294,6 +10566,10 @@
             <a:prstDash val="solid"/>
           </a:ln>
         </p:spPr>
+        <p:txBody>
+          <a:bodyPr/>
+          <a:p/>
+        </p:txBody>
       </p:sp>
       <p:sp>
         <p:nvSpPr>
@@ -10580,6 +10856,10 @@
             <a:prstDash val="solid"/>
           </a:ln>
         </p:spPr>
+        <p:txBody>
+          <a:bodyPr/>
+          <a:p/>
+        </p:txBody>
       </p:sp>
       <p:sp>
         <p:nvSpPr>
@@ -10607,6 +10887,10 @@
             <a:prstDash val="solid"/>
           </a:ln>
         </p:spPr>
+        <p:txBody>
+          <a:bodyPr/>
+          <a:p/>
+        </p:txBody>
       </p:sp>
       <p:sp>
         <p:nvSpPr>
@@ -10744,6 +11028,10 @@
             <a:prstDash val="solid"/>
           </a:ln>
         </p:spPr>
+        <p:txBody>
+          <a:bodyPr/>
+          <a:p/>
+        </p:txBody>
       </p:sp>
       <p:sp>
         <p:nvSpPr>
@@ -10771,6 +11059,10 @@
             <a:prstDash val="solid"/>
           </a:ln>
         </p:spPr>
+        <p:txBody>
+          <a:bodyPr/>
+          <a:p/>
+        </p:txBody>
       </p:sp>
       <p:sp>
         <p:nvSpPr>
@@ -10908,6 +11200,10 @@
             <a:prstDash val="solid"/>
           </a:ln>
         </p:spPr>
+        <p:txBody>
+          <a:bodyPr/>
+          <a:p/>
+        </p:txBody>
       </p:sp>
       <p:sp>
         <p:nvSpPr>
@@ -10935,6 +11231,10 @@
             <a:prstDash val="solid"/>
           </a:ln>
         </p:spPr>
+        <p:txBody>
+          <a:bodyPr/>
+          <a:p/>
+        </p:txBody>
       </p:sp>
       <p:sp>
         <p:nvSpPr>
@@ -11072,6 +11372,10 @@
             <a:prstDash val="solid"/>
           </a:ln>
         </p:spPr>
+        <p:txBody>
+          <a:bodyPr/>
+          <a:p/>
+        </p:txBody>
       </p:sp>
       <p:sp>
         <p:nvSpPr>
@@ -11099,6 +11403,10 @@
             <a:prstDash val="solid"/>
           </a:ln>
         </p:spPr>
+        <p:txBody>
+          <a:bodyPr/>
+          <a:p/>
+        </p:txBody>
       </p:sp>
       <p:sp>
         <p:nvSpPr>
@@ -11236,6 +11544,10 @@
             <a:prstDash val="solid"/>
           </a:ln>
         </p:spPr>
+        <p:txBody>
+          <a:bodyPr/>
+          <a:p/>
+        </p:txBody>
       </p:sp>
       <p:sp>
         <p:nvSpPr>

</xml_diff>